<commit_message>
Botão de baixar a apresentação na tela inicial; site usa a versão de assets/
Co-Authored-By: Claude Sonnet 5.5 <noreply@anthropic.com>
Claude-Session: https://claude.ai/code/session_01H6KgGhETS6o9Y4iR26wo8X
</commit_message>
<xml_diff>
--- a/public/BI_Data_Generator_Apresentacao.pptx
+++ b/public/BI_Data_Generator_Apresentacao.pptx
@@ -3755,7 +3755,7 @@
                 </a:solidFill>
                 <a:latin typeface="Segoe UI Semibold"/>
               </a:rPr>
-              <a:t>200 SETORES  ·  10.689 MEDIDAS DAX  ·  11 FERRAMENTAS</a:t>
+              <a:t>200 SETORES  ·  10.691 MEDIDAS DAX  ·  11 FERRAMENTAS</a:t>
             </a:r>
           </a:p>
         </p:txBody>
@@ -11438,7 +11438,7 @@
                 </a:solidFill>
                 <a:latin typeface="Segoe UI Semibold"/>
               </a:rPr>
-              <a:t>10.689</a:t>
+              <a:t>10.691</a:t>
             </a:r>
             <a:r>
               <a:rPr sz="4600" b="1" i="0" dirty="0">

</xml_diff>